<commit_message>
Revised PPT download to allow multi Type/Subtype combis, included fill_text_data in PPT output
</commit_message>
<xml_diff>
--- a/Files/PPT_Template/Proposed_Barebones.pptx
+++ b/Files/PPT_Template/Proposed_Barebones.pptx
@@ -123,6 +123,197 @@
 </p188:authorLst>
 </file>
 
+<file path=ppt/changesInfos/changesInfo1.xml><?xml version="1.0" encoding="utf-8"?>
+<pc:chgInfo xmlns:a="http://schemas.openxmlformats.org/drawingml/2006/main" xmlns:r="http://schemas.openxmlformats.org/officeDocument/2006/relationships" xmlns:ac="http://schemas.microsoft.com/office/drawing/2013/main/command" xmlns:pc="http://schemas.microsoft.com/office/powerpoint/2013/main/command">
+  <pc:docChgLst>
+    <pc:chgData name="John Lee" userId="58a3f885-1391-4760-a61f-6b2196835268" providerId="ADAL" clId="{F2373257-779C-4B55-98FF-27A5B4DD2F23}"/>
+    <pc:docChg chg="undo custSel addSld delSld modSld modMainMaster">
+      <pc:chgData name="John Lee" userId="58a3f885-1391-4760-a61f-6b2196835268" providerId="ADAL" clId="{F2373257-779C-4B55-98FF-27A5B4DD2F23}" dt="2026-01-20T08:13:47.862" v="48" actId="47"/>
+      <pc:docMkLst>
+        <pc:docMk/>
+      </pc:docMkLst>
+      <pc:sldChg chg="new del">
+        <pc:chgData name="John Lee" userId="58a3f885-1391-4760-a61f-6b2196835268" providerId="ADAL" clId="{F2373257-779C-4B55-98FF-27A5B4DD2F23}" dt="2026-01-20T04:06:15.605" v="5" actId="47"/>
+        <pc:sldMkLst>
+          <pc:docMk/>
+          <pc:sldMk cId="1084820843" sldId="256"/>
+        </pc:sldMkLst>
+      </pc:sldChg>
+      <pc:sldChg chg="addSp delSp modSp new del mod modClrScheme chgLayout">
+        <pc:chgData name="John Lee" userId="58a3f885-1391-4760-a61f-6b2196835268" providerId="ADAL" clId="{F2373257-779C-4B55-98FF-27A5B4DD2F23}" dt="2026-01-20T08:13:47.862" v="48" actId="47"/>
+        <pc:sldMkLst>
+          <pc:docMk/>
+          <pc:sldMk cId="2050039404" sldId="256"/>
+        </pc:sldMkLst>
+        <pc:spChg chg="del">
+          <ac:chgData name="John Lee" userId="58a3f885-1391-4760-a61f-6b2196835268" providerId="ADAL" clId="{F2373257-779C-4B55-98FF-27A5B4DD2F23}" dt="2026-01-20T08:13:40.553" v="46" actId="700"/>
+          <ac:spMkLst>
+            <pc:docMk/>
+            <pc:sldMk cId="2050039404" sldId="256"/>
+            <ac:spMk id="2" creationId="{93512787-DA9E-DA92-D2A2-83731C02BA11}"/>
+          </ac:spMkLst>
+        </pc:spChg>
+        <pc:spChg chg="mod ord">
+          <ac:chgData name="John Lee" userId="58a3f885-1391-4760-a61f-6b2196835268" providerId="ADAL" clId="{F2373257-779C-4B55-98FF-27A5B4DD2F23}" dt="2026-01-20T08:13:43.296" v="47" actId="700"/>
+          <ac:spMkLst>
+            <pc:docMk/>
+            <pc:sldMk cId="2050039404" sldId="256"/>
+            <ac:spMk id="3" creationId="{FC416B96-E490-3257-8230-DE338DB6821F}"/>
+          </ac:spMkLst>
+        </pc:spChg>
+        <pc:spChg chg="add mod ord">
+          <ac:chgData name="John Lee" userId="58a3f885-1391-4760-a61f-6b2196835268" providerId="ADAL" clId="{F2373257-779C-4B55-98FF-27A5B4DD2F23}" dt="2026-01-20T08:13:40.553" v="46" actId="700"/>
+          <ac:spMkLst>
+            <pc:docMk/>
+            <pc:sldMk cId="2050039404" sldId="256"/>
+            <ac:spMk id="4" creationId="{96528E41-2F19-3FEA-D76C-3A0DA0407E1E}"/>
+          </ac:spMkLst>
+        </pc:spChg>
+        <pc:spChg chg="add del mod ord">
+          <ac:chgData name="John Lee" userId="58a3f885-1391-4760-a61f-6b2196835268" providerId="ADAL" clId="{F2373257-779C-4B55-98FF-27A5B4DD2F23}" dt="2026-01-20T08:13:43.296" v="47" actId="700"/>
+          <ac:spMkLst>
+            <pc:docMk/>
+            <pc:sldMk cId="2050039404" sldId="256"/>
+            <ac:spMk id="5" creationId="{96782DC2-D175-3EDC-5C88-6D54374754B1}"/>
+          </ac:spMkLst>
+        </pc:spChg>
+        <pc:spChg chg="add mod ord">
+          <ac:chgData name="John Lee" userId="58a3f885-1391-4760-a61f-6b2196835268" providerId="ADAL" clId="{F2373257-779C-4B55-98FF-27A5B4DD2F23}" dt="2026-01-20T08:13:40.553" v="46" actId="700"/>
+          <ac:spMkLst>
+            <pc:docMk/>
+            <pc:sldMk cId="2050039404" sldId="256"/>
+            <ac:spMk id="6" creationId="{3D9153F3-0F3C-491A-910E-FA48B0668282}"/>
+          </ac:spMkLst>
+        </pc:spChg>
+        <pc:spChg chg="add del mod ord">
+          <ac:chgData name="John Lee" userId="58a3f885-1391-4760-a61f-6b2196835268" providerId="ADAL" clId="{F2373257-779C-4B55-98FF-27A5B4DD2F23}" dt="2026-01-20T08:13:43.296" v="47" actId="700"/>
+          <ac:spMkLst>
+            <pc:docMk/>
+            <pc:sldMk cId="2050039404" sldId="256"/>
+            <ac:spMk id="7" creationId="{E5F1A054-3E7F-62E2-B360-FCC0A6BE02AD}"/>
+          </ac:spMkLst>
+        </pc:spChg>
+        <pc:spChg chg="add del mod ord">
+          <ac:chgData name="John Lee" userId="58a3f885-1391-4760-a61f-6b2196835268" providerId="ADAL" clId="{F2373257-779C-4B55-98FF-27A5B4DD2F23}" dt="2026-01-20T08:13:43.296" v="47" actId="700"/>
+          <ac:spMkLst>
+            <pc:docMk/>
+            <pc:sldMk cId="2050039404" sldId="256"/>
+            <ac:spMk id="8" creationId="{A70A17D4-F3B6-E440-DB74-A6D2D3DA8D90}"/>
+          </ac:spMkLst>
+        </pc:spChg>
+        <pc:spChg chg="add del mod ord">
+          <ac:chgData name="John Lee" userId="58a3f885-1391-4760-a61f-6b2196835268" providerId="ADAL" clId="{F2373257-779C-4B55-98FF-27A5B4DD2F23}" dt="2026-01-20T08:13:43.296" v="47" actId="700"/>
+          <ac:spMkLst>
+            <pc:docMk/>
+            <pc:sldMk cId="2050039404" sldId="256"/>
+            <ac:spMk id="9" creationId="{AC6B6616-2F44-1B73-92E3-C1D57317D9B8}"/>
+          </ac:spMkLst>
+        </pc:spChg>
+        <pc:spChg chg="add del mod ord">
+          <ac:chgData name="John Lee" userId="58a3f885-1391-4760-a61f-6b2196835268" providerId="ADAL" clId="{F2373257-779C-4B55-98FF-27A5B4DD2F23}" dt="2026-01-20T08:13:43.296" v="47" actId="700"/>
+          <ac:spMkLst>
+            <pc:docMk/>
+            <pc:sldMk cId="2050039404" sldId="256"/>
+            <ac:spMk id="10" creationId="{B4ACA059-11E9-DC84-1CC5-DB52FF91565A}"/>
+          </ac:spMkLst>
+        </pc:spChg>
+        <pc:spChg chg="add mod ord">
+          <ac:chgData name="John Lee" userId="58a3f885-1391-4760-a61f-6b2196835268" providerId="ADAL" clId="{F2373257-779C-4B55-98FF-27A5B4DD2F23}" dt="2026-01-20T08:13:43.296" v="47" actId="700"/>
+          <ac:spMkLst>
+            <pc:docMk/>
+            <pc:sldMk cId="2050039404" sldId="256"/>
+            <ac:spMk id="11" creationId="{7FF5EBC4-0BA2-F3E5-D6A7-6D77818669A8}"/>
+          </ac:spMkLst>
+        </pc:spChg>
+        <pc:spChg chg="add mod ord">
+          <ac:chgData name="John Lee" userId="58a3f885-1391-4760-a61f-6b2196835268" providerId="ADAL" clId="{F2373257-779C-4B55-98FF-27A5B4DD2F23}" dt="2026-01-20T08:13:43.296" v="47" actId="700"/>
+          <ac:spMkLst>
+            <pc:docMk/>
+            <pc:sldMk cId="2050039404" sldId="256"/>
+            <ac:spMk id="12" creationId="{751AE098-9104-BDED-D700-D9BDAE2752CF}"/>
+          </ac:spMkLst>
+        </pc:spChg>
+        <pc:spChg chg="add mod ord">
+          <ac:chgData name="John Lee" userId="58a3f885-1391-4760-a61f-6b2196835268" providerId="ADAL" clId="{F2373257-779C-4B55-98FF-27A5B4DD2F23}" dt="2026-01-20T08:13:43.296" v="47" actId="700"/>
+          <ac:spMkLst>
+            <pc:docMk/>
+            <pc:sldMk cId="2050039404" sldId="256"/>
+            <ac:spMk id="14" creationId="{7D380070-230E-ACD0-2CC7-958D07D020A7}"/>
+          </ac:spMkLst>
+        </pc:spChg>
+        <pc:spChg chg="add mod ord">
+          <ac:chgData name="John Lee" userId="58a3f885-1391-4760-a61f-6b2196835268" providerId="ADAL" clId="{F2373257-779C-4B55-98FF-27A5B4DD2F23}" dt="2026-01-20T08:13:43.296" v="47" actId="700"/>
+          <ac:spMkLst>
+            <pc:docMk/>
+            <pc:sldMk cId="2050039404" sldId="256"/>
+            <ac:spMk id="16" creationId="{BEA8CDC5-2C7A-9FA1-5801-3C6F4060A20D}"/>
+          </ac:spMkLst>
+        </pc:spChg>
+      </pc:sldChg>
+      <pc:sldMasterChg chg="modSldLayout">
+        <pc:chgData name="John Lee" userId="58a3f885-1391-4760-a61f-6b2196835268" providerId="ADAL" clId="{F2373257-779C-4B55-98FF-27A5B4DD2F23}" dt="2026-01-20T08:13:30.347" v="44" actId="14100"/>
+        <pc:sldMasterMkLst>
+          <pc:docMk/>
+          <pc:sldMasterMk cId="1807529114" sldId="2147483673"/>
+        </pc:sldMasterMkLst>
+        <pc:sldLayoutChg chg="modSp mod">
+          <pc:chgData name="John Lee" userId="58a3f885-1391-4760-a61f-6b2196835268" providerId="ADAL" clId="{F2373257-779C-4B55-98FF-27A5B4DD2F23}" dt="2026-01-20T04:04:43.564" v="2" actId="122"/>
+          <pc:sldLayoutMkLst>
+            <pc:docMk/>
+            <pc:sldMasterMk cId="1807529114" sldId="2147483673"/>
+            <pc:sldLayoutMk cId="1992356486" sldId="2147483681"/>
+          </pc:sldLayoutMkLst>
+          <pc:spChg chg="mod">
+            <ac:chgData name="John Lee" userId="58a3f885-1391-4760-a61f-6b2196835268" providerId="ADAL" clId="{F2373257-779C-4B55-98FF-27A5B4DD2F23}" dt="2026-01-20T04:04:43.564" v="2" actId="122"/>
+            <ac:spMkLst>
+              <pc:docMk/>
+              <pc:sldMasterMk cId="1807529114" sldId="2147483673"/>
+              <pc:sldLayoutMk cId="1992356486" sldId="2147483681"/>
+              <ac:spMk id="66" creationId="{89276815-6A5A-8111-A932-476E38E024B7}"/>
+            </ac:spMkLst>
+          </pc:spChg>
+        </pc:sldLayoutChg>
+        <pc:sldLayoutChg chg="modSp mod">
+          <pc:chgData name="John Lee" userId="58a3f885-1391-4760-a61f-6b2196835268" providerId="ADAL" clId="{F2373257-779C-4B55-98FF-27A5B4DD2F23}" dt="2026-01-20T08:13:30.347" v="44" actId="14100"/>
+          <pc:sldLayoutMkLst>
+            <pc:docMk/>
+            <pc:sldMasterMk cId="1807529114" sldId="2147483673"/>
+            <pc:sldLayoutMk cId="763541663" sldId="2147483686"/>
+          </pc:sldLayoutMkLst>
+          <pc:spChg chg="mod">
+            <ac:chgData name="John Lee" userId="58a3f885-1391-4760-a61f-6b2196835268" providerId="ADAL" clId="{F2373257-779C-4B55-98FF-27A5B4DD2F23}" dt="2026-01-20T08:13:23.826" v="42" actId="14100"/>
+            <ac:spMkLst>
+              <pc:docMk/>
+              <pc:sldMasterMk cId="1807529114" sldId="2147483673"/>
+              <pc:sldLayoutMk cId="763541663" sldId="2147483686"/>
+              <ac:spMk id="65" creationId="{ADE9A7E1-11AE-4D68-B9A2-B7E45A49D92C}"/>
+            </ac:spMkLst>
+          </pc:spChg>
+          <pc:spChg chg="mod">
+            <ac:chgData name="John Lee" userId="58a3f885-1391-4760-a61f-6b2196835268" providerId="ADAL" clId="{F2373257-779C-4B55-98FF-27A5B4DD2F23}" dt="2026-01-20T08:13:30.347" v="44" actId="14100"/>
+            <ac:spMkLst>
+              <pc:docMk/>
+              <pc:sldMasterMk cId="1807529114" sldId="2147483673"/>
+              <pc:sldLayoutMk cId="763541663" sldId="2147483686"/>
+              <ac:spMk id="66" creationId="{89276815-6A5A-8111-A932-476E38E024B7}"/>
+            </ac:spMkLst>
+          </pc:spChg>
+          <pc:spChg chg="mod">
+            <ac:chgData name="John Lee" userId="58a3f885-1391-4760-a61f-6b2196835268" providerId="ADAL" clId="{F2373257-779C-4B55-98FF-27A5B4DD2F23}" dt="2026-01-20T08:13:17.407" v="41" actId="14100"/>
+            <ac:spMkLst>
+              <pc:docMk/>
+              <pc:sldMasterMk cId="1807529114" sldId="2147483673"/>
+              <pc:sldLayoutMk cId="763541663" sldId="2147483686"/>
+              <ac:spMk id="87" creationId="{A88D6341-5A51-C427-1C83-A6BDE60683D3}"/>
+            </ac:spMkLst>
+          </pc:spChg>
+        </pc:sldLayoutChg>
+      </pc:sldMasterChg>
+    </pc:docChg>
+  </pc:docChgLst>
+</pc:chgInfo>
+</file>
+
 <file path=ppt/handoutMasters/handoutMaster1.xml><?xml version="1.0" encoding="utf-8"?>
 <p:handoutMaster xmlns:a="http://schemas.openxmlformats.org/drawingml/2006/main" xmlns:r="http://schemas.openxmlformats.org/officeDocument/2006/relationships" xmlns:p="http://schemas.openxmlformats.org/presentationml/2006/main">
   <p:cSld>
@@ -217,7 +408,7 @@
           <a:p>
             <a:fld id="{BF633581-10C8-4874-8376-93CC3B71AADA}" type="datetimeFigureOut">
               <a:rPr lang="en-SG" smtClean="0"/>
-              <a:t>9/10/2023</a:t>
+              <a:t>20/1/2026</a:t>
             </a:fld>
             <a:endParaRPr lang="en-SG"/>
           </a:p>
@@ -7799,8 +7990,8 @@
         </p:nvSpPr>
         <p:spPr>
           <a:xfrm>
-            <a:off x="1648224" y="99991"/>
-            <a:ext cx="1296000" cy="171960"/>
+            <a:off x="1648223" y="99991"/>
+            <a:ext cx="8881777" cy="171960"/>
           </a:xfrm>
           <a:prstGeom prst="rect">
             <a:avLst/>
@@ -7817,7 +8008,7 @@
             <a:noAutofit/>
           </a:bodyPr>
           <a:lstStyle>
-            <a:lvl1pPr marL="0" indent="0" algn="l">
+            <a:lvl1pPr marL="0" indent="0" algn="ctr">
               <a:buNone/>
               <a:defRPr sz="1000" b="1">
                 <a:solidFill>
@@ -8466,7 +8657,7 @@
         <p:spPr>
           <a:xfrm>
             <a:off x="354000" y="99991"/>
-            <a:ext cx="1296000" cy="171960"/>
+            <a:ext cx="1800000" cy="171960"/>
           </a:xfrm>
           <a:prstGeom prst="rect">
             <a:avLst/>
@@ -8496,10 +8687,10 @@
           <a:p>
             <a:pPr lvl="0"/>
             <a:r>
-              <a:rPr lang="en-US"/>
+              <a:rPr lang="en-US" dirty="0"/>
               <a:t>Click to edit Master text styles</a:t>
             </a:r>
-            <a:endParaRPr lang="en-SG"/>
+            <a:endParaRPr lang="en-SG" dirty="0"/>
           </a:p>
         </p:txBody>
       </p:sp>
@@ -8521,8 +8712,8 @@
         </p:nvSpPr>
         <p:spPr>
           <a:xfrm>
-            <a:off x="1650000" y="99991"/>
-            <a:ext cx="1283584" cy="171960"/>
+            <a:off x="2154000" y="99991"/>
+            <a:ext cx="7872650" cy="171960"/>
           </a:xfrm>
           <a:prstGeom prst="rect">
             <a:avLst/>
@@ -8539,7 +8730,7 @@
             <a:noAutofit/>
           </a:bodyPr>
           <a:lstStyle>
-            <a:lvl1pPr marL="0" indent="0" algn="l">
+            <a:lvl1pPr marL="0" indent="0" algn="ctr">
               <a:buNone/>
               <a:defRPr sz="1000" b="1">
                 <a:solidFill>
@@ -8552,10 +8743,10 @@
           <a:p>
             <a:pPr lvl="0"/>
             <a:r>
-              <a:rPr lang="en-US"/>
+              <a:rPr lang="en-US" dirty="0"/>
               <a:t>Click to edit Master text styles</a:t>
             </a:r>
-            <a:endParaRPr lang="en-SG"/>
+            <a:endParaRPr lang="en-SG" dirty="0"/>
           </a:p>
         </p:txBody>
       </p:sp>
@@ -8629,8 +8820,8 @@
         </p:nvSpPr>
         <p:spPr>
           <a:xfrm>
-            <a:off x="10530001" y="99991"/>
-            <a:ext cx="1296000" cy="171960"/>
+            <a:off x="10026650" y="99991"/>
+            <a:ext cx="1799351" cy="171960"/>
           </a:xfrm>
           <a:prstGeom prst="rect">
             <a:avLst/>
@@ -8663,10 +8854,10 @@
           <a:p>
             <a:pPr lvl="0"/>
             <a:r>
-              <a:rPr lang="en-US"/>
+              <a:rPr lang="en-US" dirty="0"/>
               <a:t>Click to edit Master text styles</a:t>
             </a:r>
-            <a:endParaRPr lang="en-SG"/>
+            <a:endParaRPr lang="en-SG" dirty="0"/>
           </a:p>
         </p:txBody>
       </p:sp>
@@ -10448,6 +10639,39 @@
 </file>
 
 <file path=customXml/item1.xml><?xml version="1.0" encoding="utf-8"?>
+<?mso-contentType ?>
+<FormTemplates xmlns="http://schemas.microsoft.com/sharepoint/v3/contenttype/forms">
+  <Display>DocumentLibraryForm</Display>
+  <Edit>DocumentLibraryForm</Edit>
+  <New>DocumentLibraryForm</New>
+</FormTemplates>
+</file>
+
+<file path=customXml/item2.xml><?xml version="1.0" encoding="utf-8"?>
+<p:properties xmlns:p="http://schemas.microsoft.com/office/2006/metadata/properties" xmlns:xsi="http://www.w3.org/2001/XMLSchema-instance" xmlns:pc="http://schemas.microsoft.com/office/infopath/2007/PartnerControls">
+  <documentManagement>
+    <SharedWithUsers xmlns="3c7c9d60-aeee-410d-81f2-92985471e2af">
+      <UserInfo>
+        <DisplayName>Gerald Hay</DisplayName>
+        <AccountId>29</AccountId>
+        <AccountType/>
+      </UserInfo>
+      <UserInfo>
+        <DisplayName>Glenn Lim</DisplayName>
+        <AccountId>28</AccountId>
+        <AccountType/>
+      </UserInfo>
+      <UserInfo>
+        <DisplayName>Feba James</DisplayName>
+        <AccountId>12</AccountId>
+        <AccountType/>
+      </UserInfo>
+    </SharedWithUsers>
+  </documentManagement>
+</p:properties>
+</file>
+
+<file path=customXml/item3.xml><?xml version="1.0" encoding="utf-8"?>
 <ct:contentTypeSchema xmlns:ct="http://schemas.microsoft.com/office/2006/metadata/contentType" xmlns:ma="http://schemas.microsoft.com/office/2006/metadata/properties/metaAttributes" ct:_="" ma:_="" ma:contentTypeName="Document" ma:contentTypeID="0x010100F282FEABD3D1504FBB52D417A1DCF9F4" ma:contentTypeVersion="11" ma:contentTypeDescription="Create a new document." ma:contentTypeScope="" ma:versionID="54f2c1e6161d4a3818cca961a9e8aca6">
   <xsd:schema xmlns:xsd="http://www.w3.org/2001/XMLSchema" xmlns:xs="http://www.w3.org/2001/XMLSchema" xmlns:p="http://schemas.microsoft.com/office/2006/metadata/properties" xmlns:ns2="bafb6658-0c98-401a-939f-9b973af27bfc" xmlns:ns3="3c7c9d60-aeee-410d-81f2-92985471e2af" targetNamespace="http://schemas.microsoft.com/office/2006/metadata/properties" ma:root="true" ma:fieldsID="dc2dfa497cb6065289a6fb33931d816c" ns2:_="" ns3:_="">
     <xsd:import namespace="bafb6658-0c98-401a-939f-9b973af27bfc"/>
@@ -10658,54 +10882,10 @@
 </ct:contentTypeSchema>
 </file>
 
-<file path=customXml/item2.xml><?xml version="1.0" encoding="utf-8"?>
-<p:properties xmlns:p="http://schemas.microsoft.com/office/2006/metadata/properties" xmlns:xsi="http://www.w3.org/2001/XMLSchema-instance" xmlns:pc="http://schemas.microsoft.com/office/infopath/2007/PartnerControls">
-  <documentManagement>
-    <SharedWithUsers xmlns="3c7c9d60-aeee-410d-81f2-92985471e2af">
-      <UserInfo>
-        <DisplayName>Gerald Hay</DisplayName>
-        <AccountId>29</AccountId>
-        <AccountType/>
-      </UserInfo>
-      <UserInfo>
-        <DisplayName>Glenn Lim</DisplayName>
-        <AccountId>28</AccountId>
-        <AccountType/>
-      </UserInfo>
-      <UserInfo>
-        <DisplayName>Feba James</DisplayName>
-        <AccountId>12</AccountId>
-        <AccountType/>
-      </UserInfo>
-    </SharedWithUsers>
-  </documentManagement>
-</p:properties>
-</file>
-
-<file path=customXml/item3.xml><?xml version="1.0" encoding="utf-8"?>
-<?mso-contentType ?>
-<FormTemplates xmlns="http://schemas.microsoft.com/sharepoint/v3/contenttype/forms">
-  <Display>DocumentLibraryForm</Display>
-  <Edit>DocumentLibraryForm</Edit>
-  <New>DocumentLibraryForm</New>
-</FormTemplates>
-</file>
-
 <file path=customXml/itemProps1.xml><?xml version="1.0" encoding="utf-8"?>
-<ds:datastoreItem xmlns:ds="http://schemas.openxmlformats.org/officeDocument/2006/customXml" ds:itemID="{9AA222B8-CE66-4045-A892-690A8F57FF71}">
+<ds:datastoreItem xmlns:ds="http://schemas.openxmlformats.org/officeDocument/2006/customXml" ds:itemID="{F853E8F5-F997-4691-A453-7F92913ACDF8}">
   <ds:schemaRefs>
-    <ds:schemaRef ds:uri="3c7c9d60-aeee-410d-81f2-92985471e2af"/>
-    <ds:schemaRef ds:uri="bafb6658-0c98-401a-939f-9b973af27bfc"/>
-    <ds:schemaRef ds:uri="http://purl.org/dc/elements/1.1/"/>
-    <ds:schemaRef ds:uri="http://purl.org/dc/terms/"/>
-    <ds:schemaRef ds:uri="http://schemas.microsoft.com/internal/obd"/>
-    <ds:schemaRef ds:uri="http://schemas.microsoft.com/office/2006/documentManagement/types"/>
-    <ds:schemaRef ds:uri="http://schemas.microsoft.com/office/2006/metadata/contentType"/>
-    <ds:schemaRef ds:uri="http://schemas.microsoft.com/office/2006/metadata/properties"/>
-    <ds:schemaRef ds:uri="http://schemas.microsoft.com/office/2006/metadata/properties/metaAttributes"/>
-    <ds:schemaRef ds:uri="http://schemas.microsoft.com/office/infopath/2007/PartnerControls"/>
-    <ds:schemaRef ds:uri="http://schemas.openxmlformats.org/package/2006/metadata/core-properties"/>
-    <ds:schemaRef ds:uri="http://www.w3.org/2001/XMLSchema"/>
+    <ds:schemaRef ds:uri="http://schemas.microsoft.com/sharepoint/v3/contenttype/forms"/>
   </ds:schemaRefs>
 </ds:datastoreItem>
 </file>
@@ -10728,9 +10908,20 @@
 </file>
 
 <file path=customXml/itemProps3.xml><?xml version="1.0" encoding="utf-8"?>
-<ds:datastoreItem xmlns:ds="http://schemas.openxmlformats.org/officeDocument/2006/customXml" ds:itemID="{F853E8F5-F997-4691-A453-7F92913ACDF8}">
+<ds:datastoreItem xmlns:ds="http://schemas.openxmlformats.org/officeDocument/2006/customXml" ds:itemID="{9AA222B8-CE66-4045-A892-690A8F57FF71}">
   <ds:schemaRefs>
-    <ds:schemaRef ds:uri="http://schemas.microsoft.com/sharepoint/v3/contenttype/forms"/>
+    <ds:schemaRef ds:uri="3c7c9d60-aeee-410d-81f2-92985471e2af"/>
+    <ds:schemaRef ds:uri="bafb6658-0c98-401a-939f-9b973af27bfc"/>
+    <ds:schemaRef ds:uri="http://purl.org/dc/elements/1.1/"/>
+    <ds:schemaRef ds:uri="http://purl.org/dc/terms/"/>
+    <ds:schemaRef ds:uri="http://schemas.microsoft.com/internal/obd"/>
+    <ds:schemaRef ds:uri="http://schemas.microsoft.com/office/2006/documentManagement/types"/>
+    <ds:schemaRef ds:uri="http://schemas.microsoft.com/office/2006/metadata/contentType"/>
+    <ds:schemaRef ds:uri="http://schemas.microsoft.com/office/2006/metadata/properties"/>
+    <ds:schemaRef ds:uri="http://schemas.microsoft.com/office/2006/metadata/properties/metaAttributes"/>
+    <ds:schemaRef ds:uri="http://schemas.microsoft.com/office/infopath/2007/PartnerControls"/>
+    <ds:schemaRef ds:uri="http://schemas.openxmlformats.org/package/2006/metadata/core-properties"/>
+    <ds:schemaRef ds:uri="http://www.w3.org/2001/XMLSchema"/>
   </ds:schemaRefs>
 </ds:datastoreItem>
 </file>
</xml_diff>